<commit_message>
Narrative-revision memo and v33 aligned to it
The memo answers the investor's feedback point by point (new intro,
bottom-up market from lab pricing units, expert iteration vs RSI, why us
as the scorer, why now as dated facts, evidence gaps with a 90-day plan)
and maps each change to v33. v33's market now uses the memo's tiers
(17-24 labs, about 3.6M-42M USD a year for finance) and states the scale
path as a condition, not a forecast.

Co-Authored-By: Claude Opus 5.5 <noreply@anthropic.com>
Claude-Session: https://claude.ai/code/session_01EKqGwTA92C8Wo4e47t73NN
</commit_message>
<xml_diff>
--- a/SimReal-BP-v33.pptx
+++ b/SimReal-BP-v33.pptx
@@ -15547,7 +15547,7 @@
                 <a:cs typeface="Newsreader"/>
                 <a:sym typeface="Newsreader"/>
               </a:rPr>
-              <a:t>每年约400万–4,600万美元</a:t>
+              <a:t>每年约360万–4,200万美元</a:t>
             </a:r>
           </a:p>
         </p:txBody>
@@ -16300,7 +16300,7 @@
                 <a:cs typeface="Newsreader"/>
                 <a:sym typeface="Newsreader"/>
               </a:rPr>
-              <a:t>17–25家实验室</a:t>
+              <a:t>17–24家实验室</a:t>
             </a:r>
           </a:p>
         </p:txBody>
@@ -16349,7 +16349,7 @@
                 <a:cs typeface="Instrument Sans"/>
                 <a:sym typeface="Instrument Sans"/>
               </a:rPr>
-              <a:t>过半预算集中在美国前沿实验室（名单见A2）</a:t>
+              <a:t>约六成预算集中在美国前沿实验室（名单见A2）</a:t>
             </a:r>
           </a:p>
         </p:txBody>
@@ -16447,7 +16447,7 @@
                 <a:cs typeface="Newsreader"/>
                 <a:sym typeface="Newsreader"/>
               </a:rPr>
-              <a:t>60万–500万</a:t>
+              <a:t>45万–450万</a:t>
             </a:r>
           </a:p>
         </p:txBody>
@@ -16525,7 +16525,7 @@
                 <a:cs typeface="Instrument Sans"/>
                 <a:sym typeface="Instrument Sans"/>
               </a:rPr>
-              <a:t>新实验室5–8家 × 每家</a:t>
+              <a:t>新实验室5–7家 × 每家</a:t>
             </a:r>
           </a:p>
         </p:txBody>
@@ -16828,7 +16828,7 @@
                 <a:cs typeface="Newsreader"/>
                 <a:sym typeface="Newsreader"/>
               </a:rPr>
-              <a:t>400万–4,600万</a:t>
+              <a:t>360万–4,200万</a:t>
             </a:r>
           </a:p>
         </p:txBody>
@@ -17359,7 +17359,7 @@
                 <a:cs typeface="Instrument Sans"/>
                 <a:sym typeface="Instrument Sans"/>
               </a:rPr>
-              <a:t>规模路径（计划）：第3年做到3个领域</a:t>
+              <a:t>规模路径（要达成的条件，不是预测）：</a:t>
             </a:r>
             <a:br>
               <a:rPr lang="zh-CN" sz="1000"/>
@@ -17367,14 +17367,14 @@
             <a:r>
               <a:rPr lang="zh-CN" sz="1000" b="0" i="0" u="none" strike="noStrike" cap="none">
                 <a:solidFill>
-                  <a:srgbClr val="C4C0B7"/>
-                </a:solidFill>
-                <a:latin typeface="Instrument Sans"/>
-                <a:ea typeface="Instrument Sans"/>
-                <a:cs typeface="Instrument Sans"/>
-                <a:sym typeface="Instrument Sans"/>
-              </a:rPr>
-              <a:t>（交易、事件预测、财务结账）× 每领域</a:t>
+                  <a:srgbClr val="E27A3F"/>
+                </a:solidFill>
+                <a:latin typeface="Instrument Sans"/>
+                <a:ea typeface="Instrument Sans"/>
+                <a:cs typeface="Instrument Sans"/>
+                <a:sym typeface="Instrument Sans"/>
+              </a:rPr>
+              <a:t>第3年约1,000万美元ARR = 约3个领域</a:t>
             </a:r>
             <a:br>
               <a:rPr lang="zh-CN" sz="1000"/>
@@ -17382,14 +17382,14 @@
             <a:r>
               <a:rPr lang="zh-CN" sz="1000" b="0" i="0" u="none" strike="noStrike" cap="none">
                 <a:solidFill>
-                  <a:srgbClr val="C4C0B7"/>
-                </a:solidFill>
-                <a:latin typeface="Instrument Sans"/>
-                <a:ea typeface="Instrument Sans"/>
-                <a:cs typeface="Instrument Sans"/>
-                <a:sym typeface="Instrument Sans"/>
-              </a:rPr>
-              <a:t>5–8家 × 每家50万–100万美元</a:t>
+                  <a:srgbClr val="E27A3F"/>
+                </a:solidFill>
+                <a:latin typeface="Instrument Sans"/>
+                <a:ea typeface="Instrument Sans"/>
+                <a:cs typeface="Instrument Sans"/>
+                <a:sym typeface="Instrument Sans"/>
+              </a:rPr>
+              <a:t>× 每领域4–5家 × 每家60万–80万美元</a:t>
             </a:r>
             <a:br>
               <a:rPr lang="zh-CN" sz="1000"/>
@@ -17397,14 +17397,14 @@
             <a:r>
               <a:rPr lang="zh-CN" sz="1000" b="0" i="0" u="none" strike="noStrike" cap="none">
                 <a:solidFill>
-                  <a:srgbClr val="E27A3F"/>
-                </a:solidFill>
-                <a:latin typeface="Instrument Sans"/>
-                <a:ea typeface="Instrument Sans"/>
-                <a:cs typeface="Instrument Sans"/>
-                <a:sym typeface="Instrument Sans"/>
-              </a:rPr>
-              <a:t>≈ 年化750万–2,400万美元</a:t>
+                  <a:srgbClr val="C4C0B7"/>
+                </a:solidFill>
+                <a:latin typeface="Instrument Sans"/>
+                <a:ea typeface="Instrument Sans"/>
+                <a:cs typeface="Instrument Sans"/>
+                <a:sym typeface="Instrument Sans"/>
+              </a:rPr>
+              <a:t>只做交易一个领域，规模不够</a:t>
             </a:r>
           </a:p>
         </p:txBody>
@@ -17555,7 +17555,7 @@
                 <a:cs typeface="Instrument Sans"/>
                 <a:sym typeface="Instrument Sans"/>
               </a:rPr>
-              <a:t>美国前沿单家 = 2–5个复杂环境 × 10万–30万美元 + 500–1,750个任务 × 800–2,000美元；中国实验室按试点或任务批次计价。以上均为假设，待首批付费试点校准。</a:t>
+              <a:t>美国前沿单家 = 2–5个复杂环境 × 10万–30万美元 + 500–1,500个任务 × 500–2,000美元；中国实验室按试点或任务批次计价。以上均为假设，待首批付费试点校准。</a:t>
             </a:r>
           </a:p>
         </p:txBody>
@@ -28747,7 +28747,7 @@
                 <a:cs typeface="Newsreader"/>
                 <a:sym typeface="Newsreader"/>
               </a:rPr>
-              <a:t>400万–4,600万美元</a:t>
+              <a:t>360万–4,200万美元</a:t>
             </a:r>
           </a:p>
         </p:txBody>
@@ -28825,7 +28825,7 @@
                 <a:cs typeface="Instrument Sans"/>
                 <a:sym typeface="Instrument Sans"/>
               </a:rPr>
-              <a:t>过半预算集中在美国前沿实验室</a:t>
+              <a:t>约六成预算集中在美国前沿实验室</a:t>
             </a:r>
           </a:p>
         </p:txBody>
@@ -33299,7 +33299,22 @@
                 <a:cs typeface="Instrument Sans"/>
                 <a:sym typeface="Instrument Sans"/>
               </a:rPr>
-              <a:t>新实验室：Thinking Machines、Reflection AI等；中国：阿里、字节、DeepSeek、</a:t>
+              <a:t>新实验室：Thinking Machines、Reflection AI、Applied Compute、Cursor、Cognition、</a:t>
+            </a:r>
+            <a:br>
+              <a:rPr lang="zh-CN" sz="850"/>
+            </a:br>
+            <a:r>
+              <a:rPr lang="zh-CN" sz="850" b="0" i="0" u="none" strike="noStrike" cap="none">
+                <a:solidFill>
+                  <a:srgbClr val="33322F"/>
+                </a:solidFill>
+                <a:latin typeface="Instrument Sans"/>
+                <a:ea typeface="Instrument Sans"/>
+                <a:cs typeface="Instrument Sans"/>
+                <a:sym typeface="Instrument Sans"/>
+              </a:rPr>
+              <a:t>Mistral、Cohere；中国：阿里、字节、DeepSeek、</a:t>
             </a:r>
             <a:br>
               <a:rPr lang="zh-CN" sz="850"/>
@@ -39008,7 +39023,7 @@
                 <a:cs typeface="Instrument Sans"/>
                 <a:sym typeface="Instrument Sans"/>
               </a:rPr>
-              <a:t>4–7家美国前沿实验室占过半预算（推算）</a:t>
+              <a:t>4–7家美国前沿实验室约占六成预算（推算）</a:t>
             </a:r>
           </a:p>
         </p:txBody>

</xml_diff>

<commit_message>
v33 and memo: apply the cross-check
Drop the remaining overclaims a skeptical reader flagged: why now no
longer says models cannot trade (it cites real-money losses); simulator
scores are not called real outcomes; the +12% is 'not yet reproduced';
competitors that also build finance environments are named in the
headline; hygiene (held-out days, hash commitments) is not sold as a moat;
the Sharpe example states its 2.6% effect; valuation comps note that
they had revenue first. Memo section 8 matches the deck; the memo
renderer keeps headings together and parses lists after a line.

Co-Authored-By: Claude Opus 5.5 <noreply@anthropic.com>
Claude-Session: https://claude.ai/code/session_01EKqGwTA92C8Wo4e47t73NN
</commit_message>
<xml_diff>
--- a/SimReal-BP-v33.pptx
+++ b/SimReal-BP-v33.pptx
@@ -6108,7 +6108,7 @@
                 <a:cs typeface="Newsreader"/>
                 <a:sym typeface="Newsreader"/>
               </a:rPr>
-              <a:t>逐笔撮合，按风险调整后的结果计分：高分必须是真做对了</a:t>
+              <a:t>逐笔撮合，按风险调整后的结果计分，分数可复算</a:t>
             </a:r>
           </a:p>
         </p:txBody>
@@ -6998,7 +6998,7 @@
                 <a:cs typeface="Instrument Sans"/>
                 <a:sym typeface="Instrument Sans"/>
               </a:rPr>
-              <a:t>AI在真实环境中完成多步任务的全过程：</a:t>
+              <a:t>AI在环境中完成多步任务的全过程：</a:t>
             </a:r>
             <a:br>
               <a:rPr lang="zh-CN" sz="1150"/>
@@ -7091,7 +7091,7 @@
                 <a:cs typeface="Instrument Sans"/>
                 <a:sym typeface="Instrument Sans"/>
               </a:rPr>
-              <a:t>按真实结果标注成败</a:t>
+              <a:t>按计分结果标注成败</a:t>
             </a:r>
           </a:p>
         </p:txBody>
@@ -7319,7 +7319,7 @@
                 <a:cs typeface="Instrument Sans"/>
                 <a:sym typeface="Instrument Sans"/>
               </a:rPr>
-              <a:t>背靠21所顶尖大学的学生和校友网络：</a:t>
+              <a:t>7,000+候补专家，来自21所顶尖大学：</a:t>
             </a:r>
             <a:br>
               <a:rPr lang="zh-CN" sz="1150"/>
@@ -7733,7 +7733,7 @@
                 <a:cs typeface="Instrument Sans"/>
                 <a:sym typeface="Instrument Sans"/>
               </a:rPr>
-              <a:t>上线前经过攻防测试</a:t>
+              <a:t>对Agent接口保密，只用于计分</a:t>
             </a:r>
           </a:p>
         </p:txBody>
@@ -8085,7 +8085,7 @@
                 <a:cs typeface="Instrument Sans"/>
                 <a:sym typeface="Instrument Sans"/>
               </a:rPr>
-              <a:t>轨迹成败由真实结果判定，不靠人工意见</a:t>
+              <a:t>轨迹成败由模拟器或事件结算判定，不靠人工意见</a:t>
             </a:r>
           </a:p>
         </p:txBody>
@@ -8163,7 +8163,7 @@
                 <a:cs typeface="Newsreader"/>
                 <a:sym typeface="Newsreader"/>
               </a:rPr>
-              <a:t>会生长</a:t>
+              <a:t>可刷新</a:t>
             </a:r>
           </a:p>
         </p:txBody>
@@ -8212,7 +8212,7 @@
                 <a:cs typeface="Instrument Sans"/>
                 <a:sym typeface="Instrument Sans"/>
               </a:rPr>
-              <a:t>模型错在哪，下一批数据就补到哪</a:t>
+              <a:t>按季度换题、换留出日（计划）</a:t>
             </a:r>
           </a:p>
         </p:txBody>
@@ -8930,7 +8930,7 @@
                 <a:cs typeface="Instrument Sans"/>
                 <a:sym typeface="Instrument Sans"/>
               </a:rPr>
-              <a:t>同一模式：AfterQuery 14个月做到年化1亿美元</a:t>
+              <a:t>参照，模式不同：AfterQuery 14个月年化1亿美元</a:t>
             </a:r>
           </a:p>
         </p:txBody>
@@ -10694,7 +10694,7 @@
                 <a:cs typeface="Newsreader"/>
                 <a:sym typeface="Newsreader"/>
               </a:rPr>
-              <a:t>单位经济（估算）</a:t>
+              <a:t>单位经济（待测算）</a:t>
             </a:r>
           </a:p>
         </p:txBody>
@@ -11585,7 +11585,7 @@
                 <a:cs typeface="Instrument Sans"/>
                 <a:sym typeface="Instrument Sans"/>
               </a:rPr>
-              <a:t>目标：12个月内2–3家付费</a:t>
+              <a:t>尚无意向书；目标12个月2–3家付费</a:t>
             </a:r>
           </a:p>
         </p:txBody>
@@ -14939,7 +14939,7 @@
                 <a:cs typeface="Newsreader"/>
                 <a:sym typeface="Newsreader"/>
               </a:rPr>
-              <a:t>每做一个领域，资产都会留下来：</a:t>
+              <a:t>计划在每个领域积累：</a:t>
             </a:r>
             <a:r>
               <a:rPr lang="zh-CN" sz="1300" b="0" i="0" u="none" strike="noStrike" cap="none">
@@ -17131,7 +17131,7 @@
                 <a:cs typeface="Instrument Sans"/>
                 <a:sym typeface="Instrument Sans"/>
               </a:rPr>
-              <a:t>每家年合同（美元）</a:t>
+              <a:t>每家平均年合同（美元）</a:t>
             </a:r>
           </a:p>
         </p:txBody>
@@ -18078,7 +18078,7 @@
                 <a:cs typeface="Newsreader"/>
                 <a:sym typeface="Newsreader"/>
               </a:rPr>
-              <a:t>别人卖专家工时或办公流程，</a:t>
+              <a:t>AfterQuery、EdotEnv也做金融环境；</a:t>
             </a:r>
             <a:r>
               <a:rPr lang="zh-CN" sz="1600" b="0" i="0" u="none" strike="noStrike" cap="none">
@@ -18090,7 +18090,7 @@
                 <a:cs typeface="Newsreader"/>
                 <a:sym typeface="Newsreader"/>
               </a:rPr>
-              <a:t>我们卖交易领域的评分器</a:t>
+              <a:t>我们的区别在撮合与评分器</a:t>
             </a:r>
           </a:p>
         </p:txBody>
@@ -18474,7 +18474,7 @@
                 <a:cs typeface="Instrument Sans"/>
                 <a:sym typeface="Instrument Sans"/>
               </a:rPr>
-              <a:t>Halluminate：投行办公流程环境</a:t>
+              <a:t>EdotEnv：市场数据RL环境，最接近</a:t>
             </a:r>
           </a:p>
           <a:p>
@@ -18500,7 +18500,7 @@
                 <a:cs typeface="Instrument Sans"/>
                 <a:sym typeface="Instrument Sans"/>
               </a:rPr>
-              <a:t>EdotEnv：RSI叙事；Prodigy：自训AI交易员</a:t>
+              <a:t>Halluminate：投行流程；Prodigy：自训交易员</a:t>
             </a:r>
           </a:p>
         </p:txBody>
@@ -18809,7 +18809,7 @@
                 <a:cs typeface="Instrument Sans"/>
                 <a:sym typeface="Instrument Sans"/>
               </a:rPr>
-              <a:t>Meta等组建内部环境团队；只做自己熟悉的领域</a:t>
+              <a:t>Meta组建内部环境团队；中国实验室大量自建</a:t>
             </a:r>
           </a:p>
         </p:txBody>
@@ -19063,7 +19063,7 @@
                 <a:cs typeface="IBM Plex Mono"/>
                 <a:sym typeface="IBM Plex Mono"/>
               </a:rPr>
-              <a:t>我们的优势</a:t>
+              <a:t>我们有什么</a:t>
             </a:r>
           </a:p>
         </p:txBody>
@@ -19193,7 +19193,7 @@
                 <a:cs typeface="Instrument Sans"/>
                 <a:sym typeface="Instrument Sans"/>
               </a:rPr>
-              <a:t>回撤扣分、夏普调整写进奖励：修好一个人类策略后，盈亏+63%，夏普却从7.27跌到3.03</a:t>
+              <a:t>回撤扣分、夏普调整写进奖励，回撤吃光利润记0分；夏普权重偏小，待校准</a:t>
             </a:r>
           </a:p>
         </p:txBody>
@@ -19323,7 +19323,7 @@
                 <a:cs typeface="Instrument Sans"/>
                 <a:sym typeface="Instrument Sans"/>
               </a:rPr>
-              <a:t>模拟器计分、留出交易日、结果哈希预先公开；同一策略同一分</a:t>
+              <a:t>模拟器计分、留出日、哈希承诺：行业通行做法，我们已公开做到</a:t>
             </a:r>
           </a:p>
         </p:txBody>
@@ -19453,7 +19453,7 @@
                 <a:cs typeface="Instrument Sans"/>
                 <a:sym typeface="Instrument Sans"/>
               </a:rPr>
-              <a:t>未公开的任务用于换题和检验数据污染，公开榜单饱和后照样能用</a:t>
+              <a:t>未公开的任务用于换题；数据同样来自公开竞赛，防污染效果待验证</a:t>
             </a:r>
           </a:p>
         </p:txBody>
@@ -20182,7 +20182,7 @@
                 <a:cs typeface="Newsreader"/>
                 <a:sym typeface="Newsreader"/>
               </a:rPr>
-              <a:t>高分必须是真做对了</a:t>
+              <a:t>防的是模型钻评分的空子</a:t>
             </a:r>
           </a:p>
         </p:txBody>
@@ -20309,7 +20309,7 @@
                 <a:cs typeface="Newsreader"/>
                 <a:sym typeface="Newsreader"/>
               </a:rPr>
-              <a:t>撮合真实</a:t>
+              <a:t>逐笔撮合</a:t>
             </a:r>
           </a:p>
         </p:txBody>
@@ -20543,7 +20543,7 @@
                 <a:cs typeface="Instrument Sans"/>
                 <a:sym typeface="Instrument Sans"/>
               </a:rPr>
-              <a:t>总分 = max(0, 盈亏 − 0.1×回撤) × 夏普系数</a:t>
+              <a:t>A = max(0, 盈亏 − 0.1×回撤) × 夏普系数</a:t>
             </a:r>
           </a:p>
           <a:p>
@@ -20569,7 +20569,7 @@
                 <a:cs typeface="Instrument Sans"/>
                 <a:sym typeface="Instrument Sans"/>
               </a:rPr>
-              <a:t>盈亏和夏普会背离：修好一个人类策略后，</a:t>
+              <a:t>修好一个人类策略：盈亏+63%，</a:t>
             </a:r>
           </a:p>
           <a:p>
@@ -20595,7 +20595,33 @@
                 <a:cs typeface="Instrument Sans"/>
                 <a:sym typeface="Instrument Sans"/>
               </a:rPr>
-              <a:t>盈亏+63%，夏普从7.27跌到3.03</a:t>
+              <a:t>夏普7.27→3.03，A中夏普系数只降2.6%；</a:t>
+            </a:r>
+          </a:p>
+          <a:p>
+            <a:pPr marL="0" marR="0" lvl="0" indent="0" algn="l" rtl="0">
+              <a:lnSpc>
+                <a:spcPct val="114999"/>
+              </a:lnSpc>
+              <a:spcBef>
+                <a:spcPts val="200"/>
+              </a:spcBef>
+              <a:spcAft>
+                <a:spcPts val="0"/>
+              </a:spcAft>
+              <a:buNone/>
+            </a:pPr>
+            <a:r>
+              <a:rPr lang="zh-CN" sz="1100" b="0" i="0" u="none" strike="noStrike" cap="none">
+                <a:solidFill>
+                  <a:srgbClr val="33322F"/>
+                </a:solidFill>
+                <a:latin typeface="Instrument Sans"/>
+                <a:ea typeface="Instrument Sans"/>
+                <a:cs typeface="Instrument Sans"/>
+                <a:sym typeface="Instrument Sans"/>
+              </a:rPr>
+              <a:t>夏普权重待校准</a:t>
             </a:r>
           </a:p>
         </p:txBody>
@@ -20907,7 +20933,7 @@
                 <a:cs typeface="Instrument Sans"/>
                 <a:sym typeface="Instrument Sans"/>
               </a:rPr>
-              <a:t>Jane Street、Citadel、Optiver量化实习</a:t>
+              <a:t>Jane Street、Citadel、Optiver量化经历</a:t>
             </a:r>
           </a:p>
           <a:p>
@@ -21219,7 +21245,7 @@
                 <a:cs typeface="Instrument Sans"/>
                 <a:sym typeface="Instrument Sans"/>
               </a:rPr>
-              <a:t>用储备任务与真实行情任务补上</a:t>
+              <a:t>储备任务只能部分排除，授权行情任务在计划中</a:t>
             </a:r>
           </a:p>
         </p:txBody>
@@ -21268,7 +21294,7 @@
                 <a:cs typeface="Newsreader"/>
                 <a:sym typeface="Newsreader"/>
               </a:rPr>
-              <a:t>交易里学到的纪律，正是RL环境最缺的：</a:t>
+              <a:t>抗reward hacking是买方关键标准之一：</a:t>
             </a:r>
             <a:r>
               <a:rPr lang="zh-CN" sz="2000" b="0" i="0" u="none" strike="noStrike" cap="none">
@@ -21280,7 +21306,7 @@
                 <a:cs typeface="Newsreader"/>
                 <a:sym typeface="Newsreader"/>
               </a:rPr>
-              <a:t>不让模型钻评分的空子</a:t>
+              <a:t>交易里，它取决于撮合和奖励设计</a:t>
             </a:r>
             <a:r>
               <a:rPr lang="zh-CN" sz="2000" b="0" i="0" u="none" strike="noStrike" cap="none">
@@ -23657,7 +23683,7 @@
                 <a:cs typeface="Newsreader"/>
                 <a:sym typeface="Newsreader"/>
               </a:rPr>
-              <a:t>本轮投后5亿元人民币（约7,400万美元）：</a:t>
+              <a:t>参照公司都是先有收入再拿高估值：</a:t>
             </a:r>
             <a:r>
               <a:rPr lang="zh-CN" sz="1700" b="0" i="0" u="none" strike="noStrike" cap="none">
@@ -23669,7 +23695,7 @@
                 <a:cs typeface="Newsreader"/>
                 <a:sym typeface="Newsreader"/>
               </a:rPr>
-              <a:t>约为AfterQuery A轮投后的四分之一</a:t>
+              <a:t>本轮投后5亿元人民币（约7,400万美元），首批合同是关键</a:t>
             </a:r>
             <a:r>
               <a:rPr lang="zh-CN" sz="1700" b="0" i="0" u="none" strike="noStrike" cap="none">
@@ -24253,7 +24279,7 @@
                 <a:cs typeface="Newsreader"/>
                 <a:sym typeface="Newsreader"/>
               </a:rPr>
-              <a:t>两台引擎：收入引擎赚今天的钱，</a:t>
+              <a:t>两台引擎：收入引擎拿下首批合同，</a:t>
             </a:r>
             <a:r>
               <a:rPr lang="zh-CN" sz="1600" b="0" i="0" u="none" strike="noStrike" cap="none">
@@ -25246,7 +25272,7 @@
                 <a:cs typeface="Instrument Sans"/>
                 <a:sym typeface="Instrument Sans"/>
               </a:rPr>
-              <a:t>跑道24个月；行业环境单价2万–30万美元（Epoch AI）</a:t>
+              <a:t>跑道24个月；软件复刻环境单价2万–30万美元（Epoch AI）</a:t>
             </a:r>
           </a:p>
         </p:txBody>
@@ -27086,7 +27112,7 @@
                 <a:cs typeface="Newsreader"/>
                 <a:sym typeface="Newsreader"/>
               </a:rPr>
-              <a:t>高分，</a:t>
+              <a:t>分数可复算，</a:t>
             </a:r>
           </a:p>
           <a:p>
@@ -27112,7 +27138,7 @@
                 <a:cs typeface="Newsreader"/>
                 <a:sym typeface="Newsreader"/>
               </a:rPr>
-              <a:t>必须是真做对了。</a:t>
+              <a:t>增益才可信。</a:t>
             </a:r>
           </a:p>
         </p:txBody>
@@ -27161,7 +27187,7 @@
                 <a:cs typeface="Instrument Sans"/>
                 <a:sym typeface="Instrument Sans"/>
               </a:rPr>
-              <a:t>7个基准与环境已上线；交易是第一个跑通专家迭代的领域</a:t>
+              <a:t>7个基准与环境已上线；交易上已完成一轮专家迭代</a:t>
             </a:r>
           </a:p>
         </p:txBody>
@@ -27774,7 +27800,7 @@
                 <a:cs typeface="Newsreader"/>
                 <a:sym typeface="Newsreader"/>
               </a:rPr>
-              <a:t>高分必须是真做对了</a:t>
+              <a:t>分数可复算</a:t>
             </a:r>
           </a:p>
         </p:txBody>
@@ -28620,7 +28646,7 @@
                 <a:cs typeface="Instrument Sans"/>
                 <a:sym typeface="Instrument Sans"/>
               </a:rPr>
-              <a:t>Jane Street、Citadel、Optiver量化实习；Millennium</a:t>
+              <a:t>Jane Street、Citadel、Optiver量化经历；Millennium</a:t>
             </a:r>
           </a:p>
         </p:txBody>
@@ -30170,7 +30196,7 @@
                 <a:cs typeface="Instrument Sans"/>
                 <a:sym typeface="Instrument Sans"/>
               </a:rPr>
-              <a:t>Xitadel公开预览版：最佳人类竞赛策略记80分；按总分，前沿模型最高77.28（GPT-6）；单个任务已有超过80分的</a:t>
+              <a:t>Xitadel公开预览版：最佳人类竞赛策略记80分；按总分，前沿模型最高77.28（GPT 6）；单个任务已有超过80分的</a:t>
             </a:r>
           </a:p>
         </p:txBody>
@@ -32167,7 +32193,7 @@
                 <a:cs typeface="Newsreader"/>
                 <a:sym typeface="Newsreader"/>
               </a:rPr>
-              <a:t>只报能复现的数字：</a:t>
+              <a:t>+12%尚未复现：</a:t>
             </a:r>
             <a:r>
               <a:rPr lang="zh-CN" sz="2000" b="0" i="0" u="none" strike="noStrike" cap="none">
@@ -32179,7 +32205,7 @@
                 <a:cs typeface="Newsreader"/>
                 <a:sym typeface="Newsreader"/>
               </a:rPr>
-              <a:t>原始记录与结果哈希在尽调时提供</a:t>
+              <a:t>原始记录在尽调时提供，多种子结果3个月内报告</a:t>
             </a:r>
             <a:r>
               <a:rPr lang="zh-CN" sz="2000" b="0" i="0" u="none" strike="noStrike" cap="none">
@@ -32665,7 +32691,7 @@
                 <a:cs typeface="Instrument Sans"/>
                 <a:sym typeface="Instrument Sans"/>
               </a:rPr>
-              <a:t>少数几家基础模型公司；约三分之二付给专家；2026年7月收购Deeptune（福布斯）</a:t>
+              <a:t>少数几家基础模型公司；约三分之二付给专家；2026年7月收购Deeptune（SiliconANGLE、TechCrunch）</a:t>
             </a:r>
           </a:p>
           <a:p>
@@ -34487,7 +34513,7 @@
                 <a:cs typeface="Newsreader"/>
                 <a:sym typeface="Newsreader"/>
               </a:rPr>
-              <a:t>真实反馈</a:t>
+              <a:t>结果反馈</a:t>
             </a:r>
           </a:p>
         </p:txBody>
@@ -34539,7 +34565,7 @@
                 <a:cs typeface="Instrument Sans"/>
                 <a:sym typeface="Instrument Sans"/>
               </a:rPr>
-              <a:t>真实发生的结果为AI的每个动作结算：</a:t>
+              <a:t>模拟器回放或真实事件的结果</a:t>
             </a:r>
             <a:br>
               <a:rPr lang="zh-CN" sz="1100"/>
@@ -34554,7 +34580,7 @@
                 <a:cs typeface="Instrument Sans"/>
                 <a:sym typeface="Instrument Sans"/>
               </a:rPr>
-              <a:t>盈亏、账目、代码能否运行、</a:t>
+              <a:t>为每个动作结算：回放盈亏、</a:t>
             </a:r>
             <a:br>
               <a:rPr lang="zh-CN" sz="1100"/>
@@ -34569,7 +34595,7 @@
                 <a:cs typeface="Instrument Sans"/>
                 <a:sym typeface="Instrument Sans"/>
               </a:rPr>
-              <a:t>事件是否发生</a:t>
+              <a:t>账目、代码能否运行、事件是否发生</a:t>
             </a:r>
           </a:p>
         </p:txBody>
@@ -34942,7 +34968,7 @@
                 <a:cs typeface="Instrument Sans"/>
                 <a:sym typeface="Instrument Sans"/>
               </a:rPr>
-              <a:t>只用于检验、从不参与训练的任务，防止模型背答案</a:t>
+              <a:t>只用于检验、不参与训练；挡不住预训练见过的公开数据</a:t>
             </a:r>
           </a:p>
         </p:txBody>
@@ -36525,7 +36551,7 @@
                 <a:cs typeface="Instrument Sans"/>
                 <a:sym typeface="Instrument Sans"/>
               </a:rPr>
-              <a:t>Instinct估值，33天涨4倍</a:t>
+              <a:t>Instinct估值，33天涨到4倍</a:t>
             </a:r>
           </a:p>
           <a:p>
@@ -37342,7 +37368,7 @@
                 <a:cs typeface="Newsreader"/>
                 <a:sym typeface="Newsreader"/>
               </a:rPr>
-              <a:t>沙盒让Agent不闯祸，</a:t>
+              <a:t>沙盒让Agent不闯祸；</a:t>
             </a:r>
             <a:r>
               <a:rPr lang="zh-CN" sz="2200" b="0" i="0" u="none" strike="noStrike" cap="none">
@@ -37354,7 +37380,7 @@
                 <a:cs typeface="Newsreader"/>
                 <a:sym typeface="Newsreader"/>
               </a:rPr>
-              <a:t>我们让它做对</a:t>
+              <a:t>我们给它一个分数可复算的练习场</a:t>
             </a:r>
             <a:r>
               <a:rPr lang="zh-CN" sz="2200" b="0" i="0" u="none" strike="noStrike" cap="none">
@@ -39477,7 +39503,7 @@
                 <a:cs typeface="Newsreader"/>
                 <a:sym typeface="Newsreader"/>
               </a:rPr>
-              <a:t>每个数字都能在尽调里复现</a:t>
+              <a:t>自有数字附原始记录，市场数字均为推算</a:t>
             </a:r>
             <a:r>
               <a:rPr lang="zh-CN" sz="2000" b="0" i="0" u="none" strike="noStrike" cap="none">
@@ -40159,7 +40185,7 @@
                 <a:cs typeface="Newsreader"/>
                 <a:sym typeface="Newsreader"/>
               </a:rPr>
-              <a:t>我们最懂做题与做事的差距</a:t>
+              <a:t>见过做题与做事的差距</a:t>
             </a:r>
           </a:p>
         </p:txBody>
@@ -41769,7 +41795,7 @@
                 <a:cs typeface="Newsreader"/>
                 <a:sym typeface="Newsreader"/>
               </a:rPr>
-              <a:t>实验室已经在为交易与金融know-how付费；</a:t>
+              <a:t>实验室已经在为金融与交易know-how付费；</a:t>
             </a:r>
             <a:r>
               <a:rPr lang="zh-CN" sz="1600" b="0" i="0" u="none" strike="noStrike" cap="none">
@@ -41781,7 +41807,7 @@
                 <a:cs typeface="Newsreader"/>
                 <a:sym typeface="Newsreader"/>
               </a:rPr>
-              <a:t>模型在交易里还赚不到钱</a:t>
+              <a:t>真钱交易里，模型多数亏损</a:t>
             </a:r>
           </a:p>
         </p:txBody>
@@ -42217,7 +42243,7 @@
                 <a:cs typeface="IBM Plex Mono"/>
                 <a:sym typeface="IBM Plex Mono"/>
               </a:rPr>
-              <a:t>模型还赚不到钱</a:t>
+              <a:t>真钱交易多数亏损</a:t>
             </a:r>
           </a:p>
         </p:txBody>
@@ -42826,7 +42852,7 @@
                 <a:cs typeface="Instrument Sans"/>
                 <a:sym typeface="Instrument Sans"/>
               </a:rPr>
-              <a:t>OpenAI推出ChatGPT for Financial Services</a:t>
+              <a:t>OpenAI推出ChatGPT for Financial Services（投行与研究，非交易）</a:t>
             </a:r>
           </a:p>
         </p:txBody>
@@ -43901,7 +43927,7 @@
                 <a:cs typeface="IBM Plex Mono"/>
                 <a:sym typeface="IBM Plex Mono"/>
               </a:rPr>
-              <a:t>真实世界：失手</a:t>
+              <a:t>实际执行：失手</a:t>
             </a:r>
           </a:p>
         </p:txBody>
@@ -44028,7 +44054,7 @@
                 <a:cs typeface="Newsreader"/>
                 <a:sym typeface="Newsreader"/>
               </a:rPr>
-              <a:t>历史回测一路上涨</a:t>
+              <a:t>训练日回测一路上涨</a:t>
             </a:r>
           </a:p>
         </p:txBody>
@@ -44126,7 +44152,7 @@
                 <a:cs typeface="Newsreader"/>
                 <a:sym typeface="Newsreader"/>
               </a:rPr>
-              <a:t>进入未见过的真实行情就亏钱</a:t>
+              <a:t>换到留出交易日就亏钱</a:t>
             </a:r>
           </a:p>
         </p:txBody>
@@ -44940,7 +44966,7 @@
                 <a:cs typeface="Newsreader"/>
                 <a:sym typeface="Newsreader"/>
               </a:rPr>
-              <a:t>用真实结果结算每个动作的环境</a:t>
+              <a:t>按规则结算、分数可复算的环境</a:t>
             </a:r>
             <a:r>
               <a:rPr lang="zh-CN" sz="2000" b="0" i="0" u="none" strike="noStrike" cap="none">
@@ -46382,7 +46408,7 @@
                 <a:cs typeface="Instrument Sans"/>
                 <a:sym typeface="Instrument Sans"/>
               </a:rPr>
-              <a:t>总分 = max(0, 盈亏 − 0.1×回撤) × 夏普系数；人类最佳记80分</a:t>
+              <a:t>A = max(0, 盈亏 − 0.1×回撤) × 夏普系数；按人类最佳的A折算为80分</a:t>
             </a:r>
           </a:p>
         </p:txBody>
@@ -48116,7 +48142,7 @@
                 <a:cs typeface="Newsreader"/>
                 <a:sym typeface="Newsreader"/>
               </a:rPr>
-              <a:t>真实结果成为下一轮训练信号</a:t>
+              <a:t>计分结果成为下一轮训练信号</a:t>
             </a:r>
           </a:p>
         </p:txBody>
@@ -48292,7 +48318,7 @@
                 <a:cs typeface="Instrument Sans"/>
                 <a:sym typeface="Instrument Sans"/>
               </a:rPr>
-              <a:t>按真实规则重建专业场景</a:t>
+              <a:t>按竞赛与业务规则重建专业场景</a:t>
             </a:r>
           </a:p>
         </p:txBody>
@@ -48468,7 +48494,7 @@
                 <a:cs typeface="Instrument Sans"/>
                 <a:sym typeface="Instrument Sans"/>
               </a:rPr>
-              <a:t>按真实结果打分，不靠另一个AI的主观判断</a:t>
+              <a:t>按规则计算的结果打分，不靠另一个AI的主观判断</a:t>
             </a:r>
           </a:p>
         </p:txBody>
@@ -48595,7 +48621,7 @@
                 <a:cs typeface="Newsreader"/>
                 <a:sym typeface="Newsreader"/>
               </a:rPr>
-              <a:t>专家反馈</a:t>
+              <a:t>专家标准</a:t>
             </a:r>
           </a:p>
         </p:txBody>
@@ -48644,7 +48670,7 @@
                 <a:cs typeface="Instrument Sans"/>
                 <a:sym typeface="Instrument Sans"/>
               </a:rPr>
-              <a:t>提供专业判断与评分标准</a:t>
+              <a:t>专家写评分标准与示范，用于数据业务</a:t>
             </a:r>
           </a:p>
         </p:txBody>
@@ -49103,7 +49129,7 @@
                 <a:cs typeface="Newsreader"/>
                 <a:sym typeface="Newsreader"/>
               </a:rPr>
-              <a:t>按真实结果结算，留下Agent轨迹</a:t>
+              <a:t>按规则结算，留下Agent轨迹</a:t>
             </a:r>
           </a:p>
         </p:txBody>
@@ -49279,7 +49305,7 @@
                 <a:cs typeface="Newsreader"/>
                 <a:sym typeface="Newsreader"/>
               </a:rPr>
-              <a:t>今天做的是专家迭代：</a:t>
+              <a:t>今天的训练是专家迭代：</a:t>
             </a:r>
             <a:r>
               <a:rPr lang="zh-CN" sz="2000" b="0" i="0" u="none" strike="noStrike" cap="none">
@@ -49352,7 +49378,7 @@
                 <a:cs typeface="Instrument Sans"/>
                 <a:sym typeface="Instrument Sans"/>
               </a:rPr>
-              <a:t>RSI（递归自我改进）需要模型改不了的外部评分器和可验证环境：金融领域的这一层，是我们在做的。</a:t>
+              <a:t>RSI（递归自我改进）需要模型改不了的外部评分器，我们做的是金融领域的这一层。</a:t>
             </a:r>
           </a:p>
         </p:txBody>
@@ -49875,7 +49901,7 @@
                 <a:cs typeface="Newsreader"/>
                 <a:sym typeface="Newsreader"/>
               </a:rPr>
-              <a:t>两周，我们在交易上</a:t>
+              <a:t>我们在交易上</a:t>
             </a:r>
             <a:r>
               <a:rPr lang="zh-CN" sz="1600" b="0" i="0" u="none" strike="noStrike" cap="none">
@@ -50462,7 +50488,7 @@
                 <a:cs typeface="Instrument Sans"/>
                 <a:sym typeface="Instrument Sans"/>
               </a:rPr>
-              <a:t>在未见过的竞赛交易日上表现最高提升12%</a:t>
+              <a:t>在留出的竞赛交易日上表现最高提升12%</a:t>
             </a:r>
           </a:p>
           <a:p>
@@ -50566,7 +50592,7 @@
                 <a:cs typeface="Newsreader"/>
                 <a:sym typeface="Newsreader"/>
               </a:rPr>
-              <a:t>交易是第一个跑通专家迭代的领域</a:t>
+              <a:t>交易上已完成一轮专家迭代，均值待报告</a:t>
             </a:r>
           </a:p>
         </p:txBody>
@@ -50742,7 +50768,7 @@
                 <a:cs typeface="Newsreader"/>
                 <a:sym typeface="Newsreader"/>
               </a:rPr>
-              <a:t>GPT-6在5/7个任务追平人类；多资产仅51分</a:t>
+              <a:t>GPT 6在5/7个任务≥人类最佳；多资产仅51分</a:t>
             </a:r>
           </a:p>
         </p:txBody>
@@ -50918,7 +50944,7 @@
                 <a:cs typeface="Instrument Sans"/>
                 <a:sym typeface="Instrument Sans"/>
               </a:rPr>
-              <a:t>GPT-6</a:t>
+              <a:t>GPT 6</a:t>
             </a:r>
           </a:p>
         </p:txBody>
@@ -53601,7 +53627,7 @@
                 <a:cs typeface="Instrument Sans"/>
                 <a:sym typeface="Instrument Sans"/>
               </a:rPr>
-              <a:t>让AI零差错完成月结</a:t>
+              <a:t>检验AI能否零差错完成月结</a:t>
             </a:r>
           </a:p>
         </p:txBody>

</xml_diff>